<commit_message>
Site updated: 2023-12-18 02:05:05
</commit_message>
<xml_diff>
--- a/ppt/mentalhealth/202312180.pptx
+++ b/ppt/mentalhealth/202312180.pptx
@@ -1300,8 +1300,8 @@
         </p:nvSpPr>
         <p:spPr>
           <a:xfrm>
-            <a:off x="7039022" y="2028825"/>
-            <a:ext cx="7438978" cy="2952750"/>
+            <a:off x="7039021" y="1431235"/>
+            <a:ext cx="8545535" cy="3550340"/>
           </a:xfrm>
           <a:prstGeom prst="rect">
             <a:avLst/>
@@ -1320,7 +1320,7 @@
               <a:buNone/>
             </a:pPr>
             <a:r>
-              <a:rPr lang="en-US" sz="6600" b="1" kern="0" spc="-143" dirty="0">
+              <a:rPr lang="en-US" sz="9600" b="1" kern="0" spc="-143" dirty="0">
                 <a:solidFill>
                   <a:srgbClr val="591CE6"/>
                 </a:solidFill>
@@ -1330,7 +1330,7 @@
               </a:rPr>
               <a:t>情绪管理</a:t>
             </a:r>
-            <a:endParaRPr lang="en-US" sz="4777" dirty="0"/>
+            <a:endParaRPr lang="en-US" sz="6600" dirty="0"/>
           </a:p>
         </p:txBody>
       </p:sp>
@@ -1560,6 +1560,36 @@
           <a:xfrm rot="652077">
             <a:off x="-389925" y="3870668"/>
             <a:ext cx="6715322" cy="4476881"/>
+          </a:xfrm>
+          <a:prstGeom prst="rect">
+            <a:avLst/>
+          </a:prstGeom>
+        </p:spPr>
+      </p:pic>
+      <p:pic>
+        <p:nvPicPr>
+          <p:cNvPr id="6" name="图片 5">
+            <a:extLst>
+              <a:ext uri="{FF2B5EF4-FFF2-40B4-BE49-F238E27FC236}">
+                <a16:creationId xmlns:a16="http://schemas.microsoft.com/office/drawing/2014/main" id="{7C882623-734A-498F-AD86-6D9C7814BA4F}"/>
+              </a:ext>
+            </a:extLst>
+          </p:cNvPr>
+          <p:cNvPicPr>
+            <a:picLocks noChangeAspect="1"/>
+          </p:cNvPicPr>
+          <p:nvPr/>
+        </p:nvPicPr>
+        <p:blipFill>
+          <a:blip r:embed="rId5"/>
+          <a:stretch>
+            <a:fillRect/>
+          </a:stretch>
+        </p:blipFill>
+        <p:spPr>
+          <a:xfrm>
+            <a:off x="12245837" y="3505200"/>
+            <a:ext cx="1847850" cy="1847850"/>
           </a:xfrm>
           <a:prstGeom prst="rect">
             <a:avLst/>
@@ -6493,6 +6523,36 @@
           </p:grpSp>
         </p:grpSp>
       </p:grpSp>
+      <p:pic>
+        <p:nvPicPr>
+          <p:cNvPr id="48" name="图片 47">
+            <a:extLst>
+              <a:ext uri="{FF2B5EF4-FFF2-40B4-BE49-F238E27FC236}">
+                <a16:creationId xmlns:a16="http://schemas.microsoft.com/office/drawing/2014/main" id="{22954EB3-3678-40DE-AF79-B60E299C3969}"/>
+              </a:ext>
+            </a:extLst>
+          </p:cNvPr>
+          <p:cNvPicPr>
+            <a:picLocks noChangeAspect="1"/>
+          </p:cNvPicPr>
+          <p:nvPr/>
+        </p:nvPicPr>
+        <p:blipFill>
+          <a:blip r:embed="rId3"/>
+          <a:stretch>
+            <a:fillRect/>
+          </a:stretch>
+        </p:blipFill>
+        <p:spPr>
+          <a:xfrm>
+            <a:off x="12741965" y="16160"/>
+            <a:ext cx="1888435" cy="1888435"/>
+          </a:xfrm>
+          <a:prstGeom prst="rect">
+            <a:avLst/>
+          </a:prstGeom>
+        </p:spPr>
+      </p:pic>
     </p:spTree>
   </p:cSld>
   <p:clrMapOvr>
@@ -7898,6 +7958,36 @@
           </p:txBody>
         </p:sp>
       </p:grpSp>
+      <p:pic>
+        <p:nvPicPr>
+          <p:cNvPr id="7" name="图片 6">
+            <a:extLst>
+              <a:ext uri="{FF2B5EF4-FFF2-40B4-BE49-F238E27FC236}">
+                <a16:creationId xmlns:a16="http://schemas.microsoft.com/office/drawing/2014/main" id="{1ADD717C-B599-42E7-A1D3-16EBF0667EEC}"/>
+              </a:ext>
+            </a:extLst>
+          </p:cNvPr>
+          <p:cNvPicPr>
+            <a:picLocks noChangeAspect="1"/>
+          </p:cNvPicPr>
+          <p:nvPr/>
+        </p:nvPicPr>
+        <p:blipFill>
+          <a:blip r:embed="rId4"/>
+          <a:stretch>
+            <a:fillRect/>
+          </a:stretch>
+        </p:blipFill>
+        <p:spPr>
+          <a:xfrm>
+            <a:off x="6751034" y="6173183"/>
+            <a:ext cx="1846174" cy="1846174"/>
+          </a:xfrm>
+          <a:prstGeom prst="rect">
+            <a:avLst/>
+          </a:prstGeom>
+        </p:spPr>
+      </p:pic>
     </p:spTree>
   </p:cSld>
   <p:clrMapOvr>

</xml_diff>